<commit_message>
Use needs and wants as marketing vocabulary
</commit_message>
<xml_diff>
--- a/second-placement/planning/2026-09-25-Function-in-Action-5-Minute-Icebreaker.pptx
+++ b/second-placement/planning/2026-09-25-Function-in-Action-5-Minute-Icebreaker.pptx
@@ -1229,6 +1229,10 @@
             <a:noFill/>
           </a:ln>
         </p:spPr>
+        <p:txBody xmlns:a="http://schemas.openxmlformats.org/drawingml/2006/main">
+          <a:bodyPr/>
+          <a:p/>
+        </p:txBody>
       </p:sp>
       <p:sp>
         <p:nvSpPr>
@@ -1375,6 +1379,10 @@
             <a:noFill/>
           </a:ln>
         </p:spPr>
+        <p:txBody xmlns:a="http://schemas.openxmlformats.org/drawingml/2006/main">
+          <a:bodyPr/>
+          <a:p/>
+        </p:txBody>
       </p:sp>
       <p:sp>
         <p:nvSpPr>
@@ -1521,6 +1529,10 @@
             <a:noFill/>
           </a:ln>
         </p:spPr>
+        <p:txBody xmlns:a="http://schemas.openxmlformats.org/drawingml/2006/main">
+          <a:bodyPr/>
+          <a:p/>
+        </p:txBody>
       </p:sp>
       <p:sp>
         <p:nvSpPr>
@@ -1667,6 +1679,10 @@
             <a:noFill/>
           </a:ln>
         </p:spPr>
+        <p:txBody xmlns:a="http://schemas.openxmlformats.org/drawingml/2006/main">
+          <a:bodyPr/>
+          <a:p/>
+        </p:txBody>
       </p:sp>
       <p:sp>
         <p:nvSpPr>
@@ -1777,7 +1793,7 @@
                 <a:ea typeface="Avenir Next"/>
                 <a:cs typeface="Avenir Next"/>
               </a:rPr>
-              <a:t>Name one customer need or benefit.</a:t>
+              <a:t>Name one customer need or want.</a:t>
             </a:r>
           </a:p>
         </p:txBody>
@@ -1813,6 +1829,10 @@
             <a:noFill/>
           </a:ln>
         </p:spPr>
+        <p:txBody xmlns:a="http://schemas.openxmlformats.org/drawingml/2006/main">
+          <a:bodyPr/>
+          <a:p/>
+        </p:txBody>
       </p:sp>
       <p:sp>
         <p:nvSpPr>
@@ -2102,6 +2122,10 @@
             <a:noFill/>
           </a:ln>
         </p:spPr>
+        <p:txBody xmlns:a="http://schemas.openxmlformats.org/drawingml/2006/main">
+          <a:bodyPr/>
+          <a:p/>
+        </p:txBody>
       </p:sp>
       <p:sp>
         <p:nvSpPr>
@@ -2248,6 +2272,10 @@
             <a:noFill/>
           </a:ln>
         </p:spPr>
+        <p:txBody xmlns:a="http://schemas.openxmlformats.org/drawingml/2006/main">
+          <a:bodyPr/>
+          <a:p/>
+        </p:txBody>
       </p:sp>
       <p:sp>
         <p:nvSpPr>
@@ -2394,6 +2422,10 @@
             <a:noFill/>
           </a:ln>
         </p:spPr>
+        <p:txBody xmlns:a="http://schemas.openxmlformats.org/drawingml/2006/main">
+          <a:bodyPr/>
+          <a:p/>
+        </p:txBody>
       </p:sp>
       <p:sp>
         <p:nvSpPr>
@@ -2597,6 +2629,10 @@
             <a:noFill/>
           </a:ln>
         </p:spPr>
+        <p:txBody xmlns:a="http://schemas.openxmlformats.org/drawingml/2006/main">
+          <a:bodyPr/>
+          <a:p/>
+        </p:txBody>
       </p:sp>
       <p:sp>
         <p:nvSpPr>
@@ -2800,6 +2836,10 @@
             <a:noFill/>
           </a:ln>
         </p:spPr>
+        <p:txBody xmlns:a="http://schemas.openxmlformats.org/drawingml/2006/main">
+          <a:bodyPr/>
+          <a:p/>
+        </p:txBody>
       </p:sp>
       <p:sp>
         <p:nvSpPr>
@@ -3003,6 +3043,10 @@
             <a:noFill/>
           </a:ln>
         </p:spPr>
+        <p:txBody xmlns:a="http://schemas.openxmlformats.org/drawingml/2006/main">
+          <a:bodyPr/>
+          <a:p/>
+        </p:txBody>
       </p:sp>
       <p:sp>
         <p:nvSpPr>
@@ -3206,6 +3250,10 @@
             <a:noFill/>
           </a:ln>
         </p:spPr>
+        <p:txBody xmlns:a="http://schemas.openxmlformats.org/drawingml/2006/main">
+          <a:bodyPr/>
+          <a:p/>
+        </p:txBody>
       </p:sp>
       <p:sp>
         <p:nvSpPr>
@@ -3381,6 +3429,10 @@
             <a:noFill/>
           </a:ln>
         </p:spPr>
+        <p:txBody xmlns:a="http://schemas.openxmlformats.org/drawingml/2006/main">
+          <a:bodyPr/>
+          <a:p/>
+        </p:txBody>
       </p:sp>
       <p:sp>
         <p:nvSpPr>
@@ -3527,6 +3579,10 @@
             <a:noFill/>
           </a:ln>
         </p:spPr>
+        <p:txBody xmlns:a="http://schemas.openxmlformats.org/drawingml/2006/main">
+          <a:bodyPr/>
+          <a:p/>
+        </p:txBody>
       </p:sp>
       <p:sp>
         <p:nvSpPr>
@@ -3616,6 +3672,10 @@
             <a:noFill/>
           </a:ln>
         </p:spPr>
+        <p:txBody xmlns:a="http://schemas.openxmlformats.org/drawingml/2006/main">
+          <a:bodyPr/>
+          <a:p/>
+        </p:txBody>
       </p:sp>
       <p:sp>
         <p:nvSpPr>

</xml_diff>

<commit_message>
Keep needs and wants distinct in summary
</commit_message>
<xml_diff>
--- a/second-placement/planning/2026-09-25-Function-in-Action-5-Minute-Icebreaker.pptx
+++ b/second-placement/planning/2026-09-25-Function-in-Action-5-Minute-Icebreaker.pptx
@@ -3814,7 +3814,7 @@
                 <a:ea typeface="Avenir Next"/>
                 <a:cs typeface="Avenir Next"/>
               </a:rPr>
-              <a:t>The customer needs ______.</a:t>
+              <a:t>The customer needs or wants ______.</a:t>
             </a:r>
           </a:p>
           <a:p xmlns:a="http://schemas.openxmlformats.org/drawingml/2006/main">
@@ -3842,7 +3842,7 @@
                 <a:ea typeface="Avenir Next"/>
                 <a:cs typeface="Avenir Next"/>
               </a:rPr>
-              <a:t>The marketing concept is to satisfy that need and make money.</a:t>
+              <a:t>The marketing concept is to satisfy that need or want and make money.</a:t>
             </a:r>
           </a:p>
           <a:p xmlns:a="http://schemas.openxmlformats.org/drawingml/2006/main">

</xml_diff>

<commit_message>
Build UDL choices into marketing starter
</commit_message>
<xml_diff>
--- a/second-placement/planning/2026-09-25-Function-in-Action-5-Minute-Icebreaker.pptx
+++ b/second-placement/planning/2026-09-25-Function-in-Action-5-Minute-Icebreaker.pptx
@@ -1493,7 +1493,7 @@
                 <a:ea typeface="Avenir Next"/>
                 <a:cs typeface="Avenir Next"/>
               </a:rPr>
-              <a:t>Use something we heard today.</a:t>
+              <a:t>Choose your starting point: a company, app, place, or experience from today.</a:t>
             </a:r>
           </a:p>
         </p:txBody>
@@ -2057,7 +2057,7 @@
                 <a:ea typeface="Avenir Next"/>
                 <a:cs typeface="Avenir Next"/>
               </a:rPr>
-              <a:t>You may speak, point, write keywords, or read the frame.</a:t>
+              <a:t>Choose your way: speak, point, write keywords, or partner-share.</a:t>
             </a:r>
           </a:p>
         </p:txBody>
@@ -2386,7 +2386,7 @@
                 <a:ea typeface="Avenir Next"/>
                 <a:cs typeface="Avenir Next"/>
               </a:rPr>
-              <a:t>Pick one function. Explain the action, not just the label.</a:t>
+              <a:t>Use the word bank + action clue. If unsure, compare two functions.</a:t>
             </a:r>
           </a:p>
         </p:txBody>
@@ -3307,7 +3307,7 @@
                 <a:ea typeface="Avenir Next"/>
                 <a:cs typeface="Avenir Next"/>
               </a:rPr>
-              <a:t>Partner prompt: “What would the company actually do?”</a:t>
+              <a:t>Partner prompt: “What would the company actually do?” Ask for a clue if needed.</a:t>
             </a:r>
           </a:p>
         </p:txBody>
@@ -3364,7 +3364,7 @@
                 <a:ea typeface="Avenir Next"/>
                 <a:cs typeface="Avenir Next"/>
               </a:rPr>
-              <a:t>Teacher move: ask a leading question; do not supply the answer.</a:t>
+              <a:t>UDL choice: say it, write it, point to the term, or read the frame.</a:t>
             </a:r>
           </a:p>
         </p:txBody>
@@ -3984,7 +3984,7 @@
                 <a:ea typeface="Avenir Next"/>
                 <a:cs typeface="Avenir Next"/>
               </a:rPr>
-              <a:t>A company or experience, a customer need, one function, and one business action.</a:t>
+              <a:t>A company or experience, a customer need or want, one function, and one business action. Choose: say it, write it, point, or partner-share.</a:t>
             </a:r>
           </a:p>
         </p:txBody>

</xml_diff>